<commit_message>
Correct report for rate-limit removal picked up from main; update deck
Merging main pulled in a real product change: daily per-account scan
limits were deliberately removed from every affected edge function
(EYES, NOSE, BRAIN, NEWS verify, News Intelligence, Breach, Scam Link,
Text, Voice), along with the matching "X/3 scans today" UI. Several
claims written earlier in this session assumed those limits still
existed (Sections 1.4, 3.3, 3.5, 3.6, 4.10, 5.1, Appendix B) and are
now corrected to reflect the current deployed source, with the
security trade-off (cost/abuse exposure now resting on provider-side
quotas alone) named directly rather than left implicit.

Also updates the defence deck (security slide, evidence slide, and the
screenshot slide, now showing real production data instead of the
prior simulated set) and the defence-prep doc with Q&A covering the
rate-limit removal and the breach_scans data-integrity finding.
</commit_message>
<xml_diff>
--- a/public/DOBERMAN_Defence_Presentation.pptx
+++ b/public/DOBERMAN_Defence_Presentation.pptx
@@ -3724,7 +3724,7 @@
                 <a:ea typeface="Calibri" pitchFamily="34" charset="-122"/>
                 <a:cs typeface="Calibri" pitchFamily="34" charset="-120"/>
               </a:rPr>
-              <a:t>Rate limits enforced server-side</a:t>
+              <a:t>Rate limit removed, verified in source</a:t>
             </a:r>
             <a:endParaRPr lang="en-US" sz="1400" dirty="0"/>
           </a:p>
@@ -3763,7 +3763,7 @@
                 <a:ea typeface="Calibri" pitchFamily="34" charset="-122"/>
                 <a:cs typeface="Calibri" pitchFamily="34" charset="-120"/>
               </a:rPr>
-              <a:t>Every limited function queries usage_logs itself — a client cannot spoof or bypass its own quota.</a:t>
+              <a:t>Daily scan caps were deliberately removed during dev. usage_logs still audits — it no longer gates. Cost exposure now rests on provider quotas.</a:t>
             </a:r>
             <a:endParaRPr lang="en-US" sz="1100" dirty="0"/>
           </a:p>
@@ -4102,7 +4102,7 @@
                 <a:ea typeface="Courier New" pitchFamily="34" charset="-122"/>
                 <a:cs typeface="Courier New" pitchFamily="34" charset="-120"/>
               </a:rPr>
-              <a:t>VERIFIED</a:t>
+              <a:t>REAL EVIDENCE</a:t>
             </a:r>
             <a:endParaRPr lang="en-US" sz="1300" dirty="0"/>
           </a:p>
@@ -4141,7 +4141,7 @@
                 <a:ea typeface="Calibri" pitchFamily="34" charset="-122"/>
                 <a:cs typeface="Calibri" pitchFamily="34" charset="-120"/>
               </a:rPr>
-              <a:t>✓  Every edge function’s source, read in full</a:t>
+              <a:t>✓  26 real EYES scans pulled from production DB</a:t>
             </a:r>
             <a:endParaRPr lang="en-US" sz="1300" dirty="0"/>
           </a:p>
@@ -4180,7 +4180,7 @@
                 <a:ea typeface="Calibri" pitchFamily="34" charset="-122"/>
                 <a:cs typeface="Calibri" pitchFamily="34" charset="-120"/>
               </a:rPr>
-              <a:t>✓  Live database schema + RLS configuration</a:t>
+              <a:t>✓  2 self-evident ChatGPT images, correctly flagged</a:t>
             </a:r>
             <a:endParaRPr lang="en-US" sz="1300" dirty="0"/>
           </a:p>
@@ -4219,7 +4219,7 @@
                 <a:ea typeface="Calibri" pitchFamily="34" charset="-122"/>
                 <a:cs typeface="Calibri" pitchFamily="34" charset="-120"/>
               </a:rPr>
-              <a:t>✓  Full interface walkthrough, every module</a:t>
+              <a:t>✓  Real DAYE chat, real repeated NEWS verify</a:t>
             </a:r>
             <a:endParaRPr lang="en-US" sz="1300" dirty="0"/>
           </a:p>
@@ -4258,7 +4258,7 @@
                 <a:ea typeface="Calibri" pitchFamily="34" charset="-122"/>
                 <a:cs typeface="Calibri" pitchFamily="34" charset="-120"/>
               </a:rPr>
-              <a:t>✓  Server-side rate limiting, secret isolation</a:t>
+              <a:t>✓  6 of 9 modules have genuine historical data</a:t>
             </a:r>
             <a:endParaRPr lang="en-US" sz="1300" dirty="0"/>
           </a:p>
@@ -4363,7 +4363,7 @@
                 <a:ea typeface="Calibri" pitchFamily="34" charset="-122"/>
                 <a:cs typeface="Calibri" pitchFamily="34" charset="-120"/>
               </a:rPr>
-              <a:t>✗  Detection accuracy / false-positive rates</a:t>
+              <a:t>✗  Measured accuracy / false-positive rate</a:t>
             </a:r>
             <a:endParaRPr lang="en-US" sz="1300" dirty="0"/>
           </a:p>
@@ -4402,7 +4402,7 @@
                 <a:ea typeface="Calibri" pitchFamily="34" charset="-122"/>
                 <a:cs typeface="Calibri" pitchFamily="34" charset="-120"/>
               </a:rPr>
-              <a:t>✗  Any sample-size-based test result</a:t>
+              <a:t>✗  NOSE, Voice, Scam Link — zero real usage</a:t>
             </a:r>
             <a:endParaRPr lang="en-US" sz="1300" dirty="0"/>
           </a:p>
@@ -4480,7 +4480,7 @@
                 <a:ea typeface="Calibri" pitchFamily="34" charset="-122"/>
                 <a:cs typeface="Calibri" pitchFamily="34" charset="-120"/>
               </a:rPr>
-              <a:t>✗  Real user-acceptance testing results</a:t>
+              <a:t>✗  Real, consented user-acceptance testing</a:t>
             </a:r>
             <a:endParaRPr lang="en-US" sz="1300" dirty="0"/>
           </a:p>
@@ -4519,7 +4519,7 @@
                 <a:ea typeface="Calibri" pitchFamily="34" charset="-122"/>
                 <a:cs typeface="Calibri" pitchFamily="34" charset="-120"/>
               </a:rPr>
-              <a:t>Why: this sandbox cannot reach the live Supabase project, and EYES/NOSE/NEWS/Breach are limited to 3 uses/account/day — both stated plainly, not worked around.</a:t>
+              <a:t>Real data was pulled directly from the production database via the Supabase management API and replayed through the real frontend — live login to production was not reachable from this sandbox.</a:t>
             </a:r>
             <a:endParaRPr lang="en-US" sz="1100" dirty="0"/>
           </a:p>
@@ -4668,7 +4668,7 @@
                 <a:ea typeface="Bookman Old Style" pitchFamily="34" charset="-122"/>
                 <a:cs typeface="Bookman Old Style" pitchFamily="34" charset="-120"/>
               </a:rPr>
-              <a:t>Interface walkthrough — real UI, simulated data</a:t>
+              <a:t>Real production data, real screenshots</a:t>
             </a:r>
             <a:endParaRPr lang="en-US" sz="2800" dirty="0"/>
           </a:p>
@@ -4676,7 +4676,7 @@
       </p:sp>
       <p:pic>
         <p:nvPicPr>
-          <p:cNvPr id="4" name="Image 0" descr="/home/user/DOBERMAN-/.eval-scripts/pptx-build/shots/01-dashboard.png">    </p:cNvPr>
+          <p:cNvPr id="4" name="Image 0" descr="/home/user/DOBERMAN-/.eval-scripts/pptx-build/shots/real-01-eyes-history.png">    </p:cNvPr>
           <p:cNvPicPr>
             <a:picLocks noChangeAspect="1"/>
           </p:cNvPicPr>
@@ -4754,7 +4754,7 @@
                 <a:ea typeface="Calibri" pitchFamily="34" charset="-122"/>
                 <a:cs typeface="Calibri" pitchFamily="34" charset="-120"/>
               </a:rPr>
-              <a:t>Dashboard</a:t>
+              <a:t>26 real EYES scans</a:t>
             </a:r>
             <a:endParaRPr lang="en-US" sz="1200" dirty="0"/>
           </a:p>
@@ -4762,7 +4762,7 @@
       </p:sp>
       <p:pic>
         <p:nvPicPr>
-          <p:cNvPr id="7" name="Image 1" descr="/home/user/DOBERMAN-/.eval-scripts/pptx-build/shots/09-daye-chat.png">    </p:cNvPr>
+          <p:cNvPr id="7" name="Image 1" descr="/home/user/DOBERMAN-/.eval-scripts/pptx-build/shots/real-06-history.png">    </p:cNvPr>
           <p:cNvPicPr>
             <a:picLocks noChangeAspect="1"/>
           </p:cNvPicPr>
@@ -4840,7 +4840,7 @@
                 <a:ea typeface="Calibri" pitchFamily="34" charset="-122"/>
                 <a:cs typeface="Calibri" pitchFamily="34" charset="-120"/>
               </a:rPr>
-              <a:t>DAYE Intelligence Chat</a:t>
+              <a:t>Real aggregated History</a:t>
             </a:r>
             <a:endParaRPr lang="en-US" sz="1200" dirty="0"/>
           </a:p>
@@ -4848,7 +4848,7 @@
       </p:sp>
       <p:pic>
         <p:nvPicPr>
-          <p:cNvPr id="10" name="Image 2" descr="/home/user/DOBERMAN-/.eval-scripts/pptx-build/shots/12-breach-result.png">    </p:cNvPr>
+          <p:cNvPr id="10" name="Image 2" descr="/home/user/DOBERMAN-/.eval-scripts/pptx-build/shots/real-08-breach.png">    </p:cNvPr>
           <p:cNvPicPr>
             <a:picLocks noChangeAspect="1"/>
           </p:cNvPicPr>
@@ -4926,7 +4926,7 @@
                 <a:ea typeface="Calibri" pitchFamily="34" charset="-122"/>
                 <a:cs typeface="Calibri" pitchFamily="34" charset="-120"/>
               </a:rPr>
-              <a:t>Breach Detection</a:t>
+              <a:t>Real Breach result</a:t>
             </a:r>
             <a:endParaRPr lang="en-US" sz="1200" dirty="0"/>
           </a:p>
@@ -4965,7 +4965,7 @@
                 <a:ea typeface="Calibri" pitchFamily="34" charset="-122"/>
                 <a:cs typeface="Calibri" pitchFamily="34" charset="-120"/>
               </a:rPr>
-              <a:t>Every screenshot is the real, deployed DOBERMAN frontend, exercised through genuine interaction. Displayed data is simulated — network access to production was unavailable when this report was prepared. 16 module screenshots in total, reproduced in Appendix C.</a:t>
+              <a:t>This is the real, deployed DOBERMAN frontend, rendering real data pulled directly from the production database — real filenames, real Hive signals, real timestamps. Only the browser login is reconstructed, since live auth to production isn’t reachable from this sandbox. NOSE, Voice, and Scam Link still show simulated data — they have zero real usage to date.</a:t>
             </a:r>
             <a:endParaRPr lang="en-US" sz="1200" dirty="0"/>
           </a:p>

</xml_diff>